<commit_message>
Fix line breaks in program design deck
Co-Authored-By: Claude Sonnet 5.5 <noreply@anthropic.com>
Claude-Session: https://claude.ai/code/session_01EAJx54yEDWUst2AHK2BTn1
</commit_message>
<xml_diff>
--- a/guruguru/guruguru_program_design.pptx
+++ b/guruguru/guruguru_program_design.pptx
@@ -3940,7 +3940,7 @@
                 </a:solidFill>
                 <a:latin typeface="Yu Gothic"/>
               </a:rPr>
-              <a:t>交渉力（5フォース）</a:t>
+              <a:t>交渉力分析</a:t>
             </a:r>
           </a:p>
         </p:txBody>
@@ -5324,7 +5324,23 @@
                 </a:solidFill>
                 <a:latin typeface="Yu Gothic"/>
               </a:rPr>
-              <a:t>③ 読む（ロールプレイ）　④ 動かす（提案・ピッチ）</a:t>
+              <a:t>③ 読む（ロールプレイ）</a:t>
+            </a:r>
+          </a:p>
+          <a:p>
+            <a:pPr algn="l">
+              <a:spcBef>
+                <a:spcPts val="400"/>
+              </a:spcBef>
+            </a:pPr>
+            <a:r>
+              <a:rPr sz="1300" b="0">
+                <a:solidFill>
+                  <a:srgbClr val="3A2A24"/>
+                </a:solidFill>
+                <a:latin typeface="Yu Gothic"/>
+              </a:rPr>
+              <a:t>④ 動かす（提案・ピッチ）</a:t>
             </a:r>
           </a:p>
         </p:txBody>

</xml_diff>